<commit_message>
Add GitHub QR to final slide of deck
Co-Authored-By: Claude Fable 5 <noreply@anthropic.com>
</commit_message>
<xml_diff>
--- a/docs/AgriNova.pptx
+++ b/docs/AgriNova.pptx
@@ -2990,6 +2990,64 @@
           </a:prstGeom>
         </p:spPr>
       </p:pic>
+      <p:pic>
+        <p:nvPicPr>
+          <p:cNvPr id="8" name="Picture 7" descr="qr_github.png"/>
+          <p:cNvPicPr>
+            <a:picLocks noChangeAspect="1"/>
+          </p:cNvPicPr>
+          <p:nvPr/>
+        </p:nvPicPr>
+        <p:blipFill>
+          <a:blip r:embed="rId4"/>
+          <a:stretch>
+            <a:fillRect/>
+          </a:stretch>
+        </p:blipFill>
+        <p:spPr>
+          <a:xfrm>
+            <a:off x="914400" y="4900000"/>
+            <a:ext cx="1371600" cy="1371600"/>
+          </a:xfrm>
+          <a:prstGeom prst="rect">
+            <a:avLst/>
+          </a:prstGeom>
+        </p:spPr>
+      </p:pic>
+      <p:sp>
+        <p:nvSpPr>
+          <p:cNvPr id="9" name="TextBox 8"/>
+          <p:cNvSpPr txBox="1"/>
+          <p:nvPr/>
+        </p:nvSpPr>
+        <p:spPr>
+          <a:xfrm>
+            <a:off x="300000" y="6311600"/>
+            <a:ext cx="2600000" cy="280000"/>
+          </a:xfrm>
+          <a:prstGeom prst="rect">
+            <a:avLst/>
+          </a:prstGeom>
+          <a:noFill/>
+        </p:spPr>
+        <p:txBody>
+          <a:bodyPr wrap="none">
+            <a:spAutoFit/>
+          </a:bodyPr>
+          <a:lstStyle/>
+          <a:p>
+            <a:pPr algn="ctr"/>
+            <a:r>
+              <a:rPr sz="1100">
+                <a:solidFill>
+                  <a:srgbClr val="E7F0DC"/>
+                </a:solidFill>
+              </a:rPr>
+              <a:t>github.com/rohancodesss/agrinova</a:t>
+            </a:r>
+          </a:p>
+        </p:txBody>
+      </p:sp>
     </p:spTree>
   </p:cSld>
   <p:clrMapOvr>

</xml_diff>

<commit_message>
Deck: add website QR beside GitHub QR on final slide
Co-Authored-By: Claude Fable 5 <noreply@anthropic.com>
</commit_message>
<xml_diff>
--- a/docs/AgriNova.pptx
+++ b/docs/AgriNova.pptx
@@ -3048,6 +3048,64 @@
           </a:p>
         </p:txBody>
       </p:sp>
+      <p:pic>
+        <p:nvPicPr>
+          <p:cNvPr id="10" name="Picture 9" descr="qr_website.png"/>
+          <p:cNvPicPr>
+            <a:picLocks noChangeAspect="1"/>
+          </p:cNvPicPr>
+          <p:nvPr/>
+        </p:nvPicPr>
+        <p:blipFill>
+          <a:blip r:embed="rId5"/>
+          <a:stretch>
+            <a:fillRect/>
+          </a:stretch>
+        </p:blipFill>
+        <p:spPr>
+          <a:xfrm>
+            <a:off x="2686000" y="4900000"/>
+            <a:ext cx="1371600" cy="1371600"/>
+          </a:xfrm>
+          <a:prstGeom prst="rect">
+            <a:avLst/>
+          </a:prstGeom>
+        </p:spPr>
+      </p:pic>
+      <p:sp>
+        <p:nvSpPr>
+          <p:cNvPr id="11" name="TextBox 10"/>
+          <p:cNvSpPr txBox="1"/>
+          <p:nvPr/>
+        </p:nvSpPr>
+        <p:spPr>
+          <a:xfrm>
+            <a:off x="2436000" y="6311600"/>
+            <a:ext cx="1900000" cy="280000"/>
+          </a:xfrm>
+          <a:prstGeom prst="rect">
+            <a:avLst/>
+          </a:prstGeom>
+          <a:noFill/>
+        </p:spPr>
+        <p:txBody>
+          <a:bodyPr wrap="none">
+            <a:spAutoFit/>
+          </a:bodyPr>
+          <a:lstStyle/>
+          <a:p>
+            <a:pPr algn="ctr"/>
+            <a:r>
+              <a:rPr sz="1100">
+                <a:solidFill>
+                  <a:srgbClr val="E7F0DC"/>
+                </a:solidFill>
+              </a:rPr>
+              <a:t>rohancodesss.github.io/agrinova</a:t>
+            </a:r>
+          </a:p>
+        </p:txBody>
+      </p:sp>
     </p:spTree>
   </p:cSld>
   <p:clrMapOvr>

</xml_diff>